<commit_message>
Final commit before submission
</commit_message>
<xml_diff>
--- a/Documentation/DV_PPT_I012_I026_I034.pptx
+++ b/Documentation/DV_PPT_I012_I026_I034.pptx
@@ -3579,7 +3579,7 @@
         <p:spPr>
           <a:xfrm>
             <a:off x="1051560" y="1956706"/>
-            <a:ext cx="10332720" cy="256032"/>
+            <a:ext cx="10332720" cy="369332"/>
           </a:xfrm>
           <a:prstGeom prst="rect">
             <a:avLst/>
@@ -3601,9 +3601,23 @@
               </a:defRPr>
             </a:pPr>
             <a:r>
-              <a:rPr dirty="0"/>
+              <a:rPr dirty="0">
+                <a:hlinkClick r:id="rId2"/>
+              </a:rPr>
               <a:t>https://www.airquality.cpcb.gov.in/ccr_docs/About_AQI.pdf</a:t>
             </a:r>
+            <a:endParaRPr lang="en-IN" dirty="0"/>
+          </a:p>
+          <a:p>
+            <a:pPr algn="l">
+              <a:defRPr sz="900" b="0">
+                <a:solidFill>
+                  <a:srgbClr val="35D3DF"/>
+                </a:solidFill>
+                <a:latin typeface="Aptos"/>
+              </a:defRPr>
+            </a:pPr>
+            <a:endParaRPr dirty="0"/>
           </a:p>
         </p:txBody>
       </p:sp>
@@ -3652,8 +3666,8 @@
         </p:nvSpPr>
         <p:spPr>
           <a:xfrm>
-            <a:off x="1051560" y="2615074"/>
-            <a:ext cx="10332720" cy="256032"/>
+            <a:off x="1051560" y="2538697"/>
+            <a:ext cx="10332720" cy="369332"/>
           </a:xfrm>
           <a:prstGeom prst="rect">
             <a:avLst/>
@@ -3675,8 +3689,23 @@
               </a:defRPr>
             </a:pPr>
             <a:r>
+              <a:rPr dirty="0">
+                <a:hlinkClick r:id="rId3"/>
+              </a:rPr>
               <a:t>https://www.who.int/publications/i/item/9789240034228/</a:t>
             </a:r>
+            <a:endParaRPr lang="en-IN" dirty="0"/>
+          </a:p>
+          <a:p>
+            <a:pPr algn="l">
+              <a:defRPr sz="900" b="0">
+                <a:solidFill>
+                  <a:srgbClr val="35D3DF"/>
+                </a:solidFill>
+                <a:latin typeface="Aptos"/>
+              </a:defRPr>
+            </a:pPr>
+            <a:endParaRPr dirty="0"/>
           </a:p>
         </p:txBody>
       </p:sp>
@@ -3725,7 +3754,7 @@
         <p:spPr>
           <a:xfrm>
             <a:off x="1051560" y="3170657"/>
-            <a:ext cx="10332720" cy="256032"/>
+            <a:ext cx="10332720" cy="369332"/>
           </a:xfrm>
           <a:prstGeom prst="rect">
             <a:avLst/>
@@ -3747,9 +3776,23 @@
               </a:defRPr>
             </a:pPr>
             <a:r>
-              <a:rPr dirty="0"/>
+              <a:rPr dirty="0">
+                <a:hlinkClick r:id="rId4"/>
+              </a:rPr>
               <a:t>https://link.springer.com/article/10.1007/s10462-023-10424-4</a:t>
             </a:r>
+            <a:endParaRPr lang="en-IN" dirty="0"/>
+          </a:p>
+          <a:p>
+            <a:pPr algn="l">
+              <a:defRPr sz="900" b="0">
+                <a:solidFill>
+                  <a:srgbClr val="35D3DF"/>
+                </a:solidFill>
+                <a:latin typeface="Aptos"/>
+              </a:defRPr>
+            </a:pPr>
+            <a:endParaRPr dirty="0"/>
           </a:p>
         </p:txBody>
       </p:sp>
@@ -3799,7 +3842,7 @@
         <p:spPr>
           <a:xfrm>
             <a:off x="1051560" y="3749040"/>
-            <a:ext cx="10332720" cy="256032"/>
+            <a:ext cx="10332720" cy="369332"/>
           </a:xfrm>
           <a:prstGeom prst="rect">
             <a:avLst/>
@@ -3821,9 +3864,23 @@
               </a:defRPr>
             </a:pPr>
             <a:r>
-              <a:rPr dirty="0"/>
+              <a:rPr dirty="0">
+                <a:hlinkClick r:id="rId5"/>
+              </a:rPr>
               <a:t>https://www.sciencedirect.com/science/article/pii/S0048969725022338</a:t>
             </a:r>
+            <a:endParaRPr lang="en-IN" dirty="0"/>
+          </a:p>
+          <a:p>
+            <a:pPr algn="l">
+              <a:defRPr sz="900" b="0">
+                <a:solidFill>
+                  <a:srgbClr val="35D3DF"/>
+                </a:solidFill>
+                <a:latin typeface="Aptos"/>
+              </a:defRPr>
+            </a:pPr>
+            <a:endParaRPr dirty="0"/>
           </a:p>
         </p:txBody>
       </p:sp>
@@ -3872,7 +3929,7 @@
         <p:spPr>
           <a:xfrm>
             <a:off x="1051560" y="4344645"/>
-            <a:ext cx="10332720" cy="256032"/>
+            <a:ext cx="10332720" cy="369332"/>
           </a:xfrm>
           <a:prstGeom prst="rect">
             <a:avLst/>
@@ -3894,9 +3951,23 @@
               </a:defRPr>
             </a:pPr>
             <a:r>
-              <a:rPr dirty="0"/>
+              <a:rPr dirty="0">
+                <a:hlinkClick r:id="rId6"/>
+              </a:rPr>
               <a:t>https://www.kaggle.com/datasets/rohanrao/air-quality-data-in-india</a:t>
             </a:r>
+            <a:endParaRPr lang="en-IN" dirty="0"/>
+          </a:p>
+          <a:p>
+            <a:pPr algn="l">
+              <a:defRPr sz="900" b="0">
+                <a:solidFill>
+                  <a:srgbClr val="35D3DF"/>
+                </a:solidFill>
+                <a:latin typeface="Aptos"/>
+              </a:defRPr>
+            </a:pPr>
+            <a:endParaRPr dirty="0"/>
           </a:p>
         </p:txBody>
       </p:sp>
@@ -3954,7 +4025,7 @@
         <p:spPr>
           <a:xfrm>
             <a:off x="1051560" y="4986897"/>
-            <a:ext cx="10332720" cy="256032"/>
+            <a:ext cx="10332720" cy="369332"/>
           </a:xfrm>
           <a:prstGeom prst="rect">
             <a:avLst/>
@@ -3976,9 +4047,23 @@
               </a:defRPr>
             </a:pPr>
             <a:r>
-              <a:rPr dirty="0"/>
+              <a:rPr dirty="0">
+                <a:hlinkClick r:id="rId7"/>
+              </a:rPr>
               <a:t>https://scikit-learn.org/stable/modules/generated/sklearn.ensemble.RandomForestRegressor.html</a:t>
             </a:r>
+            <a:endParaRPr lang="en-IN" dirty="0"/>
+          </a:p>
+          <a:p>
+            <a:pPr algn="l">
+              <a:defRPr sz="900" b="0">
+                <a:solidFill>
+                  <a:srgbClr val="35D3DF"/>
+                </a:solidFill>
+                <a:latin typeface="Aptos"/>
+              </a:defRPr>
+            </a:pPr>
+            <a:endParaRPr dirty="0"/>
           </a:p>
         </p:txBody>
       </p:sp>
@@ -4084,8 +4169,8 @@
         </p:nvSpPr>
         <p:spPr>
           <a:xfrm>
-            <a:off x="1051560" y="5578915"/>
-            <a:ext cx="10332720" cy="230832"/>
+            <a:off x="1051560" y="5467963"/>
+            <a:ext cx="10332720" cy="507831"/>
           </a:xfrm>
           <a:prstGeom prst="rect">
             <a:avLst/>
@@ -4107,9 +4192,39 @@
               </a:defRPr>
             </a:pPr>
             <a:r>
-              <a:rPr lang="en-IN" dirty="0"/>
+              <a:rPr lang="en-IN" dirty="0">
+                <a:hlinkClick r:id="rId8"/>
+              </a:rPr>
               <a:t>https://app.powerbi.com/view?r=eyJrIjoiZmVhYzA4MzgtZDlhNC00NmMzLWI4NzItNDVlNWViMTkzNWYwIiwidCI6ImQxZjE0MzQ4LWYxYjUtNGEwOS1hYzk5LTdlYmYyMTNjYmM4MSIsImMiOjEwfQ%3D%3D</a:t>
             </a:r>
+            <a:endParaRPr lang="en-IN" dirty="0"/>
+          </a:p>
+          <a:p>
+            <a:pPr>
+              <a:defRPr sz="900" b="0">
+                <a:solidFill>
+                  <a:srgbClr val="35D3DF"/>
+                </a:solidFill>
+                <a:latin typeface="Aptos"/>
+              </a:defRPr>
+            </a:pPr>
+            <a:r>
+              <a:rPr lang="en-IN" dirty="0">
+                <a:hlinkClick r:id="rId9"/>
+              </a:rPr>
+              <a:t>https://mumbai-aqi-analytics.onrender.com</a:t>
+            </a:r>
+            <a:endParaRPr lang="en-IN" dirty="0"/>
+          </a:p>
+          <a:p>
+            <a:pPr>
+              <a:defRPr sz="900" b="0">
+                <a:solidFill>
+                  <a:srgbClr val="35D3DF"/>
+                </a:solidFill>
+                <a:latin typeface="Aptos"/>
+              </a:defRPr>
+            </a:pPr>
             <a:endParaRPr dirty="0"/>
           </a:p>
         </p:txBody>
@@ -4181,7 +4296,7 @@
         <p:spPr>
           <a:xfrm>
             <a:off x="1051560" y="6102724"/>
-            <a:ext cx="10332720" cy="230832"/>
+            <a:ext cx="10332720" cy="369332"/>
           </a:xfrm>
           <a:prstGeom prst="rect">
             <a:avLst/>
@@ -4203,9 +4318,22 @@
               </a:defRPr>
             </a:pPr>
             <a:r>
-              <a:rPr lang="en-IN" dirty="0"/>
+              <a:rPr lang="en-IN" dirty="0">
+                <a:hlinkClick r:id="rId10"/>
+              </a:rPr>
               <a:t>https://github.com/shubhamjatania17/DV-Mini-Project</a:t>
             </a:r>
+            <a:endParaRPr lang="en-IN" dirty="0"/>
+          </a:p>
+          <a:p>
+            <a:pPr>
+              <a:defRPr sz="900" b="0">
+                <a:solidFill>
+                  <a:srgbClr val="35D3DF"/>
+                </a:solidFill>
+                <a:latin typeface="Aptos"/>
+              </a:defRPr>
+            </a:pPr>
             <a:endParaRPr dirty="0"/>
           </a:p>
         </p:txBody>

</xml_diff>